<commit_message>
update docuementation & postman
</commit_message>
<xml_diff>
--- a/docs/Product-Variant-Block-Firefly-Redesigned.pptx
+++ b/docs/Product-Variant-Block-Firefly-Redesigned.pptx
@@ -5,7 +5,7 @@
     <p:sldMasterId id="2147483648" r:id="rId1"/>
   </p:sldMasterIdLst>
   <p:notesMasterIdLst>
-    <p:notesMasterId r:id="rId12"/>
+    <p:notesMasterId r:id="rId13"/>
   </p:notesMasterIdLst>
   <p:sldIdLst>
     <p:sldId id="256" r:id="rId2"/>
@@ -18,6 +18,7 @@
     <p:sldId id="263" r:id="rId9"/>
     <p:sldId id="264" r:id="rId10"/>
     <p:sldId id="265" r:id="rId11"/>
+    <p:sldId id="267" r:id="rId12"/>
   </p:sldIdLst>
   <p:sldSz cx="12192000" cy="6858000"/>
   <p:notesSz cx="6858000" cy="12192000"/>
@@ -121,190 +122,29 @@
 </p:presentation>
 </file>
 
-<file path=ppt/revisionInfo.xml><?xml version="1.0" encoding="utf-8"?>
-<p1510:revInfo xmlns:a="http://schemas.openxmlformats.org/drawingml/2006/main" xmlns:r="http://schemas.openxmlformats.org/officeDocument/2006/relationships" xmlns:p1510="http://schemas.microsoft.com/office/powerpoint/2015/10/main">
-  <p1510:revLst>
-    <p1510:client id="{89AEE0ED-A6FB-6C43-84E2-8FD3DB87D018}" v="1" dt="2026-08-17T12:43:02.375"/>
-  </p1510:revLst>
-</p1510:revInfo>
-</file>
-
 <file path=ppt/changesInfos/changesInfo1.xml><?xml version="1.0" encoding="utf-8"?>
 <pc:chgInfo xmlns:a="http://schemas.openxmlformats.org/drawingml/2006/main" xmlns:r="http://schemas.openxmlformats.org/officeDocument/2006/relationships" xmlns:ac="http://schemas.microsoft.com/office/drawing/2013/main/command" xmlns:pc="http://schemas.microsoft.com/office/powerpoint/2013/main/command">
   <pc:docChgLst>
     <pc:chgData name="Franck Sevin" userId="82d950c0-7bb5-4310-a4fc-a877d4bbe588" providerId="ADAL" clId="{EB9E244D-3F8B-59DF-801C-03BB392BC6F1}"/>
-    <pc:docChg chg="custSel modSld">
-      <pc:chgData name="Franck Sevin" userId="82d950c0-7bb5-4310-a4fc-a877d4bbe588" providerId="ADAL" clId="{EB9E244D-3F8B-59DF-801C-03BB392BC6F1}" dt="2026-08-17T12:43:02.453" v="15" actId="27636"/>
+    <pc:docChg chg="custSel addSld modSld">
+      <pc:chgData name="Franck Sevin" userId="82d950c0-7bb5-4310-a4fc-a877d4bbe588" providerId="ADAL" clId="{EB9E244D-3F8B-59DF-801C-03BB392BC6F1}" dt="2026-10-08T13:39:26.728" v="17" actId="1076"/>
       <pc:docMkLst>
         <pc:docMk/>
       </pc:docMkLst>
       <pc:sldChg chg="modSp mod">
-        <pc:chgData name="Franck Sevin" userId="82d950c0-7bb5-4310-a4fc-a877d4bbe588" providerId="ADAL" clId="{EB9E244D-3F8B-59DF-801C-03BB392BC6F1}" dt="2026-08-17T12:43:02.417" v="7" actId="27636"/>
-        <pc:sldMkLst>
-          <pc:docMk/>
-          <pc:sldMk cId="0" sldId="256"/>
-        </pc:sldMkLst>
-        <pc:spChg chg="mod">
-          <ac:chgData name="Franck Sevin" userId="82d950c0-7bb5-4310-a4fc-a877d4bbe588" providerId="ADAL" clId="{EB9E244D-3F8B-59DF-801C-03BB392BC6F1}" dt="2026-08-17T12:43:02.416" v="6" actId="27636"/>
-          <ac:spMkLst>
-            <pc:docMk/>
-            <pc:sldMk cId="0" sldId="256"/>
-            <ac:spMk id="4" creationId="{00000000-0000-0000-0000-000000000000}"/>
-          </ac:spMkLst>
-        </pc:spChg>
-        <pc:spChg chg="mod">
-          <ac:chgData name="Franck Sevin" userId="82d950c0-7bb5-4310-a4fc-a877d4bbe588" providerId="ADAL" clId="{EB9E244D-3F8B-59DF-801C-03BB392BC6F1}" dt="2026-08-17T12:43:02.417" v="7" actId="27636"/>
-          <ac:spMkLst>
-            <pc:docMk/>
-            <pc:sldMk cId="0" sldId="256"/>
-            <ac:spMk id="5" creationId="{00000000-0000-0000-0000-000000000000}"/>
-          </ac:spMkLst>
-        </pc:spChg>
-        <pc:spChg chg="mod">
-          <ac:chgData name="Franck Sevin" userId="82d950c0-7bb5-4310-a4fc-a877d4bbe588" providerId="ADAL" clId="{EB9E244D-3F8B-59DF-801C-03BB392BC6F1}" dt="2026-08-17T12:43:02.413" v="4" actId="27636"/>
-          <ac:spMkLst>
-            <pc:docMk/>
-            <pc:sldMk cId="0" sldId="256"/>
-            <ac:spMk id="6" creationId="{00000000-0000-0000-0000-000000000000}"/>
-          </ac:spMkLst>
-        </pc:spChg>
-        <pc:spChg chg="mod">
-          <ac:chgData name="Franck Sevin" userId="82d950c0-7bb5-4310-a4fc-a877d4bbe588" providerId="ADAL" clId="{EB9E244D-3F8B-59DF-801C-03BB392BC6F1}" dt="2026-08-17T12:43:02.414" v="5" actId="27636"/>
-          <ac:spMkLst>
-            <pc:docMk/>
-            <pc:sldMk cId="0" sldId="256"/>
-            <ac:spMk id="9" creationId="{00000000-0000-0000-0000-000000000000}"/>
-          </ac:spMkLst>
-        </pc:spChg>
-      </pc:sldChg>
-      <pc:sldChg chg="modSp mod">
-        <pc:chgData name="Franck Sevin" userId="82d950c0-7bb5-4310-a4fc-a877d4bbe588" providerId="ADAL" clId="{EB9E244D-3F8B-59DF-801C-03BB392BC6F1}" dt="2026-08-17T12:43:02.427" v="10" actId="27636"/>
-        <pc:sldMkLst>
-          <pc:docMk/>
-          <pc:sldMk cId="0" sldId="257"/>
-        </pc:sldMkLst>
-        <pc:spChg chg="mod">
-          <ac:chgData name="Franck Sevin" userId="82d950c0-7bb5-4310-a4fc-a877d4bbe588" providerId="ADAL" clId="{EB9E244D-3F8B-59DF-801C-03BB392BC6F1}" dt="2026-08-17T12:43:02.426" v="9" actId="27636"/>
-          <ac:spMkLst>
-            <pc:docMk/>
-            <pc:sldMk cId="0" sldId="257"/>
-            <ac:spMk id="14" creationId="{00000000-0000-0000-0000-000000000000}"/>
-          </ac:spMkLst>
-        </pc:spChg>
-        <pc:spChg chg="mod">
-          <ac:chgData name="Franck Sevin" userId="82d950c0-7bb5-4310-a4fc-a877d4bbe588" providerId="ADAL" clId="{EB9E244D-3F8B-59DF-801C-03BB392BC6F1}" dt="2026-08-17T12:43:02.424" v="8" actId="27636"/>
-          <ac:spMkLst>
-            <pc:docMk/>
-            <pc:sldMk cId="0" sldId="257"/>
-            <ac:spMk id="20" creationId="{00000000-0000-0000-0000-000000000000}"/>
-          </ac:spMkLst>
-        </pc:spChg>
-        <pc:spChg chg="mod">
-          <ac:chgData name="Franck Sevin" userId="82d950c0-7bb5-4310-a4fc-a877d4bbe588" providerId="ADAL" clId="{EB9E244D-3F8B-59DF-801C-03BB392BC6F1}" dt="2026-08-17T12:43:02.427" v="10" actId="27636"/>
-          <ac:spMkLst>
-            <pc:docMk/>
-            <pc:sldMk cId="0" sldId="257"/>
-            <ac:spMk id="32" creationId="{00000000-0000-0000-0000-000000000000}"/>
-          </ac:spMkLst>
-        </pc:spChg>
-      </pc:sldChg>
-      <pc:sldChg chg="modSp mod">
-        <pc:chgData name="Franck Sevin" userId="82d950c0-7bb5-4310-a4fc-a877d4bbe588" providerId="ADAL" clId="{EB9E244D-3F8B-59DF-801C-03BB392BC6F1}" dt="2026-08-17T12:43:02.433" v="11" actId="27636"/>
+        <pc:chgData name="Franck Sevin" userId="82d950c0-7bb5-4310-a4fc-a877d4bbe588" providerId="ADAL" clId="{EB9E244D-3F8B-59DF-801C-03BB392BC6F1}" dt="2026-10-08T13:39:26.728" v="17" actId="1076"/>
         <pc:sldMkLst>
           <pc:docMk/>
           <pc:sldMk cId="0" sldId="258"/>
         </pc:sldMkLst>
-        <pc:spChg chg="mod">
-          <ac:chgData name="Franck Sevin" userId="82d950c0-7bb5-4310-a4fc-a877d4bbe588" providerId="ADAL" clId="{EB9E244D-3F8B-59DF-801C-03BB392BC6F1}" dt="2026-08-17T12:43:02.433" v="11" actId="27636"/>
-          <ac:spMkLst>
+        <pc:picChg chg="mod">
+          <ac:chgData name="Franck Sevin" userId="82d950c0-7bb5-4310-a4fc-a877d4bbe588" providerId="ADAL" clId="{EB9E244D-3F8B-59DF-801C-03BB392BC6F1}" dt="2026-10-08T13:39:26.728" v="17" actId="1076"/>
+          <ac:picMkLst>
             <pc:docMk/>
             <pc:sldMk cId="0" sldId="258"/>
-            <ac:spMk id="3" creationId="{00000000-0000-0000-0000-000000000000}"/>
-          </ac:spMkLst>
-        </pc:spChg>
-      </pc:sldChg>
-      <pc:sldChg chg="modSp mod">
-        <pc:chgData name="Franck Sevin" userId="82d950c0-7bb5-4310-a4fc-a877d4bbe588" providerId="ADAL" clId="{EB9E244D-3F8B-59DF-801C-03BB392BC6F1}" dt="2026-08-17T12:43:02.437" v="12" actId="27636"/>
-        <pc:sldMkLst>
-          <pc:docMk/>
-          <pc:sldMk cId="0" sldId="259"/>
-        </pc:sldMkLst>
-        <pc:spChg chg="mod">
-          <ac:chgData name="Franck Sevin" userId="82d950c0-7bb5-4310-a4fc-a877d4bbe588" providerId="ADAL" clId="{EB9E244D-3F8B-59DF-801C-03BB392BC6F1}" dt="2026-08-17T12:43:02.437" v="12" actId="27636"/>
-          <ac:spMkLst>
-            <pc:docMk/>
-            <pc:sldMk cId="0" sldId="259"/>
-            <ac:spMk id="22" creationId="{00000000-0000-0000-0000-000000000000}"/>
-          </ac:spMkLst>
-        </pc:spChg>
-      </pc:sldChg>
-      <pc:sldChg chg="modSp mod">
-        <pc:chgData name="Franck Sevin" userId="82d950c0-7bb5-4310-a4fc-a877d4bbe588" providerId="ADAL" clId="{EB9E244D-3F8B-59DF-801C-03BB392BC6F1}" dt="2026-08-17T12:43:02.448" v="14" actId="27636"/>
-        <pc:sldMkLst>
-          <pc:docMk/>
-          <pc:sldMk cId="0" sldId="260"/>
-        </pc:sldMkLst>
-        <pc:spChg chg="mod">
-          <ac:chgData name="Franck Sevin" userId="82d950c0-7bb5-4310-a4fc-a877d4bbe588" providerId="ADAL" clId="{EB9E244D-3F8B-59DF-801C-03BB392BC6F1}" dt="2026-08-17T12:43:02.448" v="14" actId="27636"/>
-          <ac:spMkLst>
-            <pc:docMk/>
-            <pc:sldMk cId="0" sldId="260"/>
-            <ac:spMk id="7" creationId="{00000000-0000-0000-0000-000000000000}"/>
-          </ac:spMkLst>
-        </pc:spChg>
-        <pc:spChg chg="mod">
-          <ac:chgData name="Franck Sevin" userId="82d950c0-7bb5-4310-a4fc-a877d4bbe588" providerId="ADAL" clId="{EB9E244D-3F8B-59DF-801C-03BB392BC6F1}" dt="2026-08-17T12:43:02.443" v="13" actId="27636"/>
-          <ac:spMkLst>
-            <pc:docMk/>
-            <pc:sldMk cId="0" sldId="260"/>
-            <ac:spMk id="9" creationId="{00000000-0000-0000-0000-000000000000}"/>
-          </ac:spMkLst>
-        </pc:spChg>
-      </pc:sldChg>
-      <pc:sldChg chg="modSp mod">
-        <pc:chgData name="Franck Sevin" userId="82d950c0-7bb5-4310-a4fc-a877d4bbe588" providerId="ADAL" clId="{EB9E244D-3F8B-59DF-801C-03BB392BC6F1}" dt="2026-08-17T12:43:02.453" v="15" actId="27636"/>
-        <pc:sldMkLst>
-          <pc:docMk/>
-          <pc:sldMk cId="0" sldId="261"/>
-        </pc:sldMkLst>
-        <pc:spChg chg="mod">
-          <ac:chgData name="Franck Sevin" userId="82d950c0-7bb5-4310-a4fc-a877d4bbe588" providerId="ADAL" clId="{EB9E244D-3F8B-59DF-801C-03BB392BC6F1}" dt="2026-08-17T12:43:02.453" v="15" actId="27636"/>
-          <ac:spMkLst>
-            <pc:docMk/>
-            <pc:sldMk cId="0" sldId="261"/>
-            <ac:spMk id="19" creationId="{00000000-0000-0000-0000-000000000000}"/>
-          </ac:spMkLst>
-        </pc:spChg>
-      </pc:sldChg>
-      <pc:sldChg chg="modNotesTx">
-        <pc:chgData name="Franck Sevin" userId="82d950c0-7bb5-4310-a4fc-a877d4bbe588" providerId="ADAL" clId="{EB9E244D-3F8B-59DF-801C-03BB392BC6F1}" dt="2026-08-17T12:43:01.807" v="1" actId="20577"/>
-        <pc:sldMkLst>
-          <pc:docMk/>
-          <pc:sldMk cId="0" sldId="264"/>
-        </pc:sldMkLst>
-      </pc:sldChg>
-      <pc:sldChg chg="modSp mod">
-        <pc:chgData name="Franck Sevin" userId="82d950c0-7bb5-4310-a4fc-a877d4bbe588" providerId="ADAL" clId="{EB9E244D-3F8B-59DF-801C-03BB392BC6F1}" dt="2026-08-17T12:43:02.407" v="3" actId="27636"/>
-        <pc:sldMkLst>
-          <pc:docMk/>
-          <pc:sldMk cId="0" sldId="265"/>
-        </pc:sldMkLst>
-        <pc:spChg chg="mod">
-          <ac:chgData name="Franck Sevin" userId="82d950c0-7bb5-4310-a4fc-a877d4bbe588" providerId="ADAL" clId="{EB9E244D-3F8B-59DF-801C-03BB392BC6F1}" dt="2026-08-17T12:43:02.407" v="3" actId="27636"/>
-          <ac:spMkLst>
-            <pc:docMk/>
-            <pc:sldMk cId="0" sldId="265"/>
-            <ac:spMk id="3" creationId="{00000000-0000-0000-0000-000000000000}"/>
-          </ac:spMkLst>
-        </pc:spChg>
-        <pc:spChg chg="mod">
-          <ac:chgData name="Franck Sevin" userId="82d950c0-7bb5-4310-a4fc-a877d4bbe588" providerId="ADAL" clId="{EB9E244D-3F8B-59DF-801C-03BB392BC6F1}" dt="2026-08-17T12:43:02.405" v="2" actId="27636"/>
-          <ac:spMkLst>
-            <pc:docMk/>
-            <pc:sldMk cId="0" sldId="265"/>
-            <ac:spMk id="26" creationId="{00000000-0000-0000-0000-000000000000}"/>
-          </ac:spMkLst>
-        </pc:spChg>
+            <ac:picMk id="5" creationId="{00000000-0000-0000-0000-000000000000}"/>
+          </ac:picMkLst>
+        </pc:picChg>
       </pc:sldChg>
     </pc:docChg>
   </pc:docChgLst>
@@ -1554,6 +1394,101 @@
 </p:sldLayout>
 </file>
 
+<file path=ppt/slideLayouts/slideLayout3.xml><?xml version="1.0" encoding="utf-8"?>
+<p:sldLayout xmlns:a="http://schemas.openxmlformats.org/drawingml/2006/main" xmlns:r="http://schemas.openxmlformats.org/officeDocument/2006/relationships" xmlns:p="http://schemas.openxmlformats.org/presentationml/2006/main" type="blank">
+  <p:cSld name="Blank">
+    <p:spTree>
+      <p:nvGrpSpPr>
+        <p:cNvPr id="1" name=""/>
+        <p:cNvGrpSpPr/>
+        <p:nvPr/>
+      </p:nvGrpSpPr>
+      <p:grpSpPr>
+        <a:xfrm>
+          <a:off x="0" y="0"/>
+          <a:ext cx="0" cy="0"/>
+          <a:chOff x="0" y="0"/>
+          <a:chExt cx="0" cy="0"/>
+        </a:xfrm>
+      </p:grpSpPr>
+      <p:sp>
+        <p:nvSpPr>
+          <p:cNvPr id="2" name="Date Placeholder 1"/>
+          <p:cNvSpPr>
+            <a:spLocks noGrp="1"/>
+          </p:cNvSpPr>
+          <p:nvPr>
+            <p:ph type="dt" sz="half" idx="10"/>
+          </p:nvPr>
+        </p:nvSpPr>
+        <p:spPr/>
+        <p:txBody>
+          <a:bodyPr/>
+          <a:lstStyle/>
+          <a:p>
+            <a:fld id="{5BCAD085-E8A6-8845-BD4E-CB4CCA059FC4}" type="datetimeFigureOut">
+              <a:rPr lang="en-US" smtClean="0"/>
+              <a:t>10/8/26</a:t>
+            </a:fld>
+            <a:endParaRPr lang="en-US"/>
+          </a:p>
+        </p:txBody>
+      </p:sp>
+      <p:sp>
+        <p:nvSpPr>
+          <p:cNvPr id="3" name="Footer Placeholder 2"/>
+          <p:cNvSpPr>
+            <a:spLocks noGrp="1"/>
+          </p:cNvSpPr>
+          <p:nvPr>
+            <p:ph type="ftr" sz="quarter" idx="11"/>
+          </p:nvPr>
+        </p:nvSpPr>
+        <p:spPr/>
+        <p:txBody>
+          <a:bodyPr/>
+          <a:lstStyle/>
+          <a:p>
+            <a:endParaRPr lang="en-US"/>
+          </a:p>
+        </p:txBody>
+      </p:sp>
+      <p:sp>
+        <p:nvSpPr>
+          <p:cNvPr id="4" name="Slide Number Placeholder 3"/>
+          <p:cNvSpPr>
+            <a:spLocks noGrp="1"/>
+          </p:cNvSpPr>
+          <p:nvPr>
+            <p:ph type="sldNum" sz="quarter" idx="12"/>
+          </p:nvPr>
+        </p:nvSpPr>
+        <p:spPr/>
+        <p:txBody>
+          <a:bodyPr/>
+          <a:lstStyle/>
+          <a:p>
+            <a:fld id="{C1FF6DA9-008F-8B48-92A6-B652298478BF}" type="slidenum">
+              <a:rPr lang="en-US" smtClean="0"/>
+              <a:t>‹#›</a:t>
+            </a:fld>
+            <a:endParaRPr lang="en-US"/>
+          </a:p>
+        </p:txBody>
+      </p:sp>
+    </p:spTree>
+    <p:extLst>
+      <p:ext uri="{BB962C8B-B14F-4D97-AF65-F5344CB8AC3E}">
+        <p14:creationId xmlns:p14="http://schemas.microsoft.com/office/powerpoint/2010/main" val="2773613860"/>
+      </p:ext>
+    </p:extLst>
+  </p:cSld>
+  <p:clrMapOvr>
+    <a:masterClrMapping/>
+  </p:clrMapOvr>
+</p:sldLayout>
+</file>
+
 <file path=ppt/slideMasters/slideMaster1.xml><?xml version="1.0" encoding="utf-8"?>
 <p:sldMaster xmlns:a="http://schemas.openxmlformats.org/drawingml/2006/main" xmlns:r="http://schemas.openxmlformats.org/officeDocument/2006/relationships" xmlns:p="http://schemas.openxmlformats.org/presentationml/2006/main">
   <p:cSld>
@@ -1630,6 +1565,7 @@
   <p:sldLayoutIdLst>
     <p:sldLayoutId id="2147483649" r:id="rId1"/>
     <p:sldLayoutId id="2147483650" r:id="rId2"/>
+    <p:sldLayoutId id="2147483651" r:id="rId3"/>
   </p:sldLayoutIdLst>
   <p:hf sldNum="0" hdr="0" ftr="0" dt="0"/>
   <p:txStyles>
@@ -3159,6 +3095,66 @@
 </p:sld>
 </file>
 
+<file path=ppt/slides/slide11.xml><?xml version="1.0" encoding="utf-8"?>
+<p:sld xmlns:a="http://schemas.openxmlformats.org/drawingml/2006/main" xmlns:r="http://schemas.openxmlformats.org/officeDocument/2006/relationships" xmlns:p="http://schemas.openxmlformats.org/presentationml/2006/main">
+  <p:cSld>
+    <p:spTree>
+      <p:nvGrpSpPr>
+        <p:cNvPr id="1" name=""/>
+        <p:cNvGrpSpPr/>
+        <p:nvPr/>
+      </p:nvGrpSpPr>
+      <p:grpSpPr>
+        <a:xfrm>
+          <a:off x="0" y="0"/>
+          <a:ext cx="0" cy="0"/>
+          <a:chOff x="0" y="0"/>
+          <a:chExt cx="0" cy="0"/>
+        </a:xfrm>
+      </p:grpSpPr>
+      <p:pic>
+        <p:nvPicPr>
+          <p:cNvPr id="2" name="Picture 1">
+            <a:extLst>
+              <a:ext uri="{FF2B5EF4-FFF2-40B4-BE49-F238E27FC236}">
+                <a16:creationId xmlns:a16="http://schemas.microsoft.com/office/drawing/2014/main" id="{E36FA3BE-29D3-AC8A-6B6B-D326B3743C46}"/>
+              </a:ext>
+            </a:extLst>
+          </p:cNvPr>
+          <p:cNvPicPr>
+            <a:picLocks noChangeAspect="1"/>
+          </p:cNvPicPr>
+          <p:nvPr/>
+        </p:nvPicPr>
+        <p:blipFill>
+          <a:blip r:embed="rId2"/>
+          <a:stretch>
+            <a:fillRect/>
+          </a:stretch>
+        </p:blipFill>
+        <p:spPr>
+          <a:xfrm>
+            <a:off x="619427" y="660511"/>
+            <a:ext cx="10367319" cy="5831617"/>
+          </a:xfrm>
+          <a:prstGeom prst="rect">
+            <a:avLst/>
+          </a:prstGeom>
+        </p:spPr>
+      </p:pic>
+    </p:spTree>
+    <p:extLst>
+      <p:ext uri="{BB962C8B-B14F-4D97-AF65-F5344CB8AC3E}">
+        <p14:creationId xmlns:p14="http://schemas.microsoft.com/office/powerpoint/2010/main" val="3425204263"/>
+      </p:ext>
+    </p:extLst>
+  </p:cSld>
+  <p:clrMapOvr>
+    <a:masterClrMapping/>
+  </p:clrMapOvr>
+</p:sld>
+</file>
+
 <file path=ppt/slides/slide2.xml><?xml version="1.0" encoding="utf-8"?>
 <p:sld xmlns:a="http://schemas.openxmlformats.org/drawingml/2006/main" xmlns:r="http://schemas.openxmlformats.org/officeDocument/2006/relationships" xmlns:p="http://schemas.openxmlformats.org/presentationml/2006/main">
   <p:cSld name="Slide 2">
@@ -4502,7 +4498,7 @@
         </p:blipFill>
         <p:spPr>
           <a:xfrm>
-            <a:off x="687804" y="1847088"/>
+            <a:off x="656280" y="1682496"/>
             <a:ext cx="10822488" cy="4389120"/>
           </a:xfrm>
           <a:prstGeom prst="rect">

</xml_diff>